<commit_message>
brand: pitch deck cập nhật 10 phân hệ (thêm Tuyển dụng vào suite + Professional)
Co-Authored-By: Claude Opus 4.8 <noreply@anthropic.com>
</commit_message>
<xml_diff>
--- a/brand/Sapiones-pitch.pptx
+++ b/brand/Sapiones-pitch.pptx
@@ -3546,7 +3546,7 @@
                 <a:ea typeface="Calibri" pitchFamily="34" charset="-122"/>
                 <a:cs typeface="Calibri" pitchFamily="34" charset="-120"/>
               </a:rPr>
-              <a:t>9</a:t>
+              <a:t>10</a:t>
             </a:r>
             <a:endParaRPr lang="en-US" sz="4600" dirty="0"/>
           </a:p>
@@ -3782,12 +3782,12 @@
         </p:nvSpPr>
         <p:spPr>
           <a:xfrm>
-            <a:off x="548640" y="1371600"/>
-            <a:ext cx="3694176" cy="1627632"/>
+            <a:off x="548640" y="1554480"/>
+            <a:ext cx="2066544" cy="2103120"/>
           </a:xfrm>
           <a:prstGeom prst="roundRect">
             <a:avLst>
-              <a:gd name="adj" fmla="val 5618"/>
+              <a:gd name="adj" fmla="val 4425"/>
             </a:avLst>
           </a:prstGeom>
           <a:solidFill>
@@ -3816,8 +3816,8 @@
         </p:nvSpPr>
         <p:spPr>
           <a:xfrm>
-            <a:off x="548640" y="1371600"/>
-            <a:ext cx="109728" cy="1627632"/>
+            <a:off x="548640" y="1554480"/>
+            <a:ext cx="91440" cy="2103120"/>
           </a:xfrm>
           <a:prstGeom prst="roundRect">
             <a:avLst/>
@@ -3836,8 +3836,8 @@
         </p:nvSpPr>
         <p:spPr>
           <a:xfrm>
-            <a:off x="804672" y="1517904"/>
-            <a:ext cx="3236976" cy="502920"/>
+            <a:off x="786384" y="1755648"/>
+            <a:ext cx="1664208" cy="1417320"/>
           </a:xfrm>
           <a:prstGeom prst="rect">
             <a:avLst/>
@@ -3853,7 +3853,7 @@
               <a:buNone/>
             </a:pPr>
             <a:r>
-              <a:rPr lang="en-US" sz="1350" b="1" dirty="0">
+              <a:rPr lang="en-US" sz="1300" b="1" dirty="0">
                 <a:solidFill>
                   <a:srgbClr val="0F172A"/>
                 </a:solidFill>
@@ -3863,59 +3863,20 @@
               </a:rPr>
               <a:t>Hồ sơ &amp; bản địa hóa VN</a:t>
             </a:r>
-            <a:endParaRPr lang="en-US" sz="1350" dirty="0"/>
-          </a:p>
-        </p:txBody>
-      </p:sp>
-      <p:sp>
-        <p:nvSpPr>
-          <p:cNvPr id="6" name="Text 4"/>
-          <p:cNvSpPr/>
-          <p:nvPr/>
-        </p:nvSpPr>
-        <p:spPr>
-          <a:xfrm>
-            <a:off x="804672" y="2048256"/>
-            <a:ext cx="3236976" cy="850392"/>
-          </a:xfrm>
-          <a:prstGeom prst="rect">
-            <a:avLst/>
-          </a:prstGeom>
-          <a:noFill/>
-          <a:ln/>
-        </p:spPr>
-        <p:txBody>
-          <a:bodyPr wrap="square" lIns="0" tIns="0" rIns="0" bIns="0" rtlCol="0" anchor="t"/>
-          <a:lstStyle/>
-          <a:p>
-            <a:pPr indent="0" marL="0">
-              <a:buNone/>
-            </a:pPr>
-            <a:r>
-              <a:rPr lang="en-US" sz="1050" dirty="0">
-                <a:solidFill>
-                  <a:srgbClr val="475569"/>
-                </a:solidFill>
-                <a:latin typeface="Calibri" pitchFamily="34" charset="0"/>
-                <a:ea typeface="Calibri" pitchFamily="34" charset="-122"/>
-                <a:cs typeface="Calibri" pitchFamily="34" charset="-120"/>
-              </a:rPr>
-              <a:t>CCCD, MST, BHXH, người phụ thuộc, địa giới 2025, chứng chỉ</a:t>
-            </a:r>
-            <a:endParaRPr lang="en-US" sz="1050" dirty="0"/>
-          </a:p>
-        </p:txBody>
-      </p:sp>
-      <p:sp>
-        <p:nvSpPr>
-          <p:cNvPr id="7" name="Shape 5"/>
-          <p:cNvSpPr/>
-          <p:nvPr/>
-        </p:nvSpPr>
-        <p:spPr>
-          <a:xfrm>
-            <a:off x="3008376" y="1536192"/>
-            <a:ext cx="1051560" cy="274320"/>
+            <a:endParaRPr lang="en-US" sz="1300" dirty="0"/>
+          </a:p>
+        </p:txBody>
+      </p:sp>
+      <p:sp>
+        <p:nvSpPr>
+          <p:cNvPr id="6" name="Shape 4"/>
+          <p:cNvSpPr/>
+          <p:nvPr/>
+        </p:nvSpPr>
+        <p:spPr>
+          <a:xfrm>
+            <a:off x="786384" y="3246120"/>
+            <a:ext cx="822960" cy="256032"/>
           </a:xfrm>
           <a:prstGeom prst="roundRect">
             <a:avLst>
@@ -3930,14 +3891,14 @@
       </p:sp>
       <p:sp>
         <p:nvSpPr>
-          <p:cNvPr id="8" name="Text 6"/>
-          <p:cNvSpPr/>
-          <p:nvPr/>
-        </p:nvSpPr>
-        <p:spPr>
-          <a:xfrm>
-            <a:off x="3008376" y="1536192"/>
-            <a:ext cx="1051560" cy="274320"/>
+          <p:cNvPr id="7" name="Text 5"/>
+          <p:cNvSpPr/>
+          <p:nvPr/>
+        </p:nvSpPr>
+        <p:spPr>
+          <a:xfrm>
+            <a:off x="786384" y="3246120"/>
+            <a:ext cx="822960" cy="256032"/>
           </a:xfrm>
           <a:prstGeom prst="rect">
             <a:avLst/>
@@ -3961,7 +3922,7 @@
                 <a:ea typeface="Calibri" pitchFamily="34" charset="-122"/>
                 <a:cs typeface="Calibri" pitchFamily="34" charset="-120"/>
               </a:rPr>
-              <a:t>Miễn phí</a:t>
+              <a:t>Free</a:t>
             </a:r>
             <a:endParaRPr lang="en-US" sz="1250" dirty="0"/>
           </a:p>
@@ -3969,18 +3930,18 @@
       </p:sp>
       <p:sp>
         <p:nvSpPr>
-          <p:cNvPr id="9" name="Shape 7"/>
-          <p:cNvSpPr/>
-          <p:nvPr/>
-        </p:nvSpPr>
-        <p:spPr>
-          <a:xfrm>
-            <a:off x="4507992" y="1371600"/>
-            <a:ext cx="3694176" cy="1627632"/>
+          <p:cNvPr id="8" name="Shape 6"/>
+          <p:cNvSpPr/>
+          <p:nvPr/>
+        </p:nvSpPr>
+        <p:spPr>
+          <a:xfrm>
+            <a:off x="2798064" y="1554480"/>
+            <a:ext cx="2066544" cy="2103120"/>
           </a:xfrm>
           <a:prstGeom prst="roundRect">
             <a:avLst>
-              <a:gd name="adj" fmla="val 5618"/>
+              <a:gd name="adj" fmla="val 4425"/>
             </a:avLst>
           </a:prstGeom>
           <a:solidFill>
@@ -4003,14 +3964,14 @@
       </p:sp>
       <p:sp>
         <p:nvSpPr>
-          <p:cNvPr id="10" name="Shape 8"/>
-          <p:cNvSpPr/>
-          <p:nvPr/>
-        </p:nvSpPr>
-        <p:spPr>
-          <a:xfrm>
-            <a:off x="4507992" y="1371600"/>
-            <a:ext cx="109728" cy="1627632"/>
+          <p:cNvPr id="9" name="Shape 7"/>
+          <p:cNvSpPr/>
+          <p:nvPr/>
+        </p:nvSpPr>
+        <p:spPr>
+          <a:xfrm>
+            <a:off x="2798064" y="1554480"/>
+            <a:ext cx="91440" cy="2103120"/>
           </a:xfrm>
           <a:prstGeom prst="roundRect">
             <a:avLst/>
@@ -4023,14 +3984,14 @@
       </p:sp>
       <p:sp>
         <p:nvSpPr>
-          <p:cNvPr id="11" name="Text 9"/>
-          <p:cNvSpPr/>
-          <p:nvPr/>
-        </p:nvSpPr>
-        <p:spPr>
-          <a:xfrm>
-            <a:off x="4764024" y="1517904"/>
-            <a:ext cx="3236976" cy="502920"/>
+          <p:cNvPr id="10" name="Text 8"/>
+          <p:cNvSpPr/>
+          <p:nvPr/>
+        </p:nvSpPr>
+        <p:spPr>
+          <a:xfrm>
+            <a:off x="3035808" y="1755648"/>
+            <a:ext cx="1664208" cy="1417320"/>
           </a:xfrm>
           <a:prstGeom prst="rect">
             <a:avLst/>
@@ -4046,7 +4007,7 @@
               <a:buNone/>
             </a:pPr>
             <a:r>
-              <a:rPr lang="en-US" sz="1350" b="1" dirty="0">
+              <a:rPr lang="en-US" sz="1300" b="1" dirty="0">
                 <a:solidFill>
                   <a:srgbClr val="0F172A"/>
                 </a:solidFill>
@@ -4056,63 +4017,24 @@
               </a:rPr>
               <a:t>Tính lương Việt Nam</a:t>
             </a:r>
-            <a:endParaRPr lang="en-US" sz="1350" dirty="0"/>
-          </a:p>
-        </p:txBody>
-      </p:sp>
-      <p:sp>
-        <p:nvSpPr>
-          <p:cNvPr id="12" name="Text 10"/>
-          <p:cNvSpPr/>
-          <p:nvPr/>
-        </p:nvSpPr>
-        <p:spPr>
-          <a:xfrm>
-            <a:off x="4764024" y="2048256"/>
-            <a:ext cx="3236976" cy="850392"/>
-          </a:xfrm>
-          <a:prstGeom prst="rect">
-            <a:avLst/>
-          </a:prstGeom>
-          <a:noFill/>
-          <a:ln/>
-        </p:spPr>
-        <p:txBody>
-          <a:bodyPr wrap="square" lIns="0" tIns="0" rIns="0" bIns="0" rtlCol="0" anchor="t"/>
-          <a:lstStyle/>
-          <a:p>
-            <a:pPr indent="0" marL="0">
-              <a:buNone/>
-            </a:pPr>
-            <a:r>
-              <a:rPr lang="en-US" sz="1050" dirty="0">
-                <a:solidFill>
-                  <a:srgbClr val="475569"/>
-                </a:solidFill>
-                <a:latin typeface="Calibri" pitchFamily="34" charset="0"/>
-                <a:ea typeface="Calibri" pitchFamily="34" charset="-122"/>
-                <a:cs typeface="Calibri" pitchFamily="34" charset="-120"/>
-              </a:rPr>
-              <a:t>Gross→net, phiếu lương PDF, file NH, bảng kê</a:t>
-            </a:r>
-            <a:endParaRPr lang="en-US" sz="1050" dirty="0"/>
-          </a:p>
-        </p:txBody>
-      </p:sp>
-      <p:sp>
-        <p:nvSpPr>
-          <p:cNvPr id="13" name="Shape 11"/>
-          <p:cNvSpPr/>
-          <p:nvPr/>
-        </p:nvSpPr>
-        <p:spPr>
-          <a:xfrm>
-            <a:off x="8467344" y="1371600"/>
-            <a:ext cx="3694176" cy="1627632"/>
+            <a:endParaRPr lang="en-US" sz="1300" dirty="0"/>
+          </a:p>
+        </p:txBody>
+      </p:sp>
+      <p:sp>
+        <p:nvSpPr>
+          <p:cNvPr id="11" name="Shape 9"/>
+          <p:cNvSpPr/>
+          <p:nvPr/>
+        </p:nvSpPr>
+        <p:spPr>
+          <a:xfrm>
+            <a:off x="5047488" y="1554480"/>
+            <a:ext cx="2066544" cy="2103120"/>
           </a:xfrm>
           <a:prstGeom prst="roundRect">
             <a:avLst>
-              <a:gd name="adj" fmla="val 5618"/>
+              <a:gd name="adj" fmla="val 4425"/>
             </a:avLst>
           </a:prstGeom>
           <a:solidFill>
@@ -4135,116 +4057,77 @@
       </p:sp>
       <p:sp>
         <p:nvSpPr>
+          <p:cNvPr id="12" name="Shape 10"/>
+          <p:cNvSpPr/>
+          <p:nvPr/>
+        </p:nvSpPr>
+        <p:spPr>
+          <a:xfrm>
+            <a:off x="5047488" y="1554480"/>
+            <a:ext cx="91440" cy="2103120"/>
+          </a:xfrm>
+          <a:prstGeom prst="roundRect">
+            <a:avLst/>
+          </a:prstGeom>
+          <a:solidFill>
+            <a:srgbClr val="4F46E5"/>
+          </a:solidFill>
+          <a:ln/>
+        </p:spPr>
+      </p:sp>
+      <p:sp>
+        <p:nvSpPr>
+          <p:cNvPr id="13" name="Text 11"/>
+          <p:cNvSpPr/>
+          <p:nvPr/>
+        </p:nvSpPr>
+        <p:spPr>
+          <a:xfrm>
+            <a:off x="5285232" y="1755648"/>
+            <a:ext cx="1664208" cy="1417320"/>
+          </a:xfrm>
+          <a:prstGeom prst="rect">
+            <a:avLst/>
+          </a:prstGeom>
+          <a:noFill/>
+          <a:ln/>
+        </p:spPr>
+        <p:txBody>
+          <a:bodyPr wrap="square" lIns="0" tIns="0" rIns="0" bIns="0" rtlCol="0" anchor="t"/>
+          <a:lstStyle/>
+          <a:p>
+            <a:pPr indent="0" marL="0">
+              <a:buNone/>
+            </a:pPr>
+            <a:r>
+              <a:rPr lang="en-US" sz="1300" b="1" dirty="0">
+                <a:solidFill>
+                  <a:srgbClr val="0F172A"/>
+                </a:solidFill>
+                <a:latin typeface="Calibri" pitchFamily="34" charset="0"/>
+                <a:ea typeface="Calibri" pitchFamily="34" charset="-122"/>
+                <a:cs typeface="Calibri" pitchFamily="34" charset="-120"/>
+              </a:rPr>
+              <a:t>Chấm công ca kíp &amp; tăng ca</a:t>
+            </a:r>
+            <a:endParaRPr lang="en-US" sz="1300" dirty="0"/>
+          </a:p>
+        </p:txBody>
+      </p:sp>
+      <p:sp>
+        <p:nvSpPr>
           <p:cNvPr id="14" name="Shape 12"/>
           <p:cNvSpPr/>
           <p:nvPr/>
         </p:nvSpPr>
         <p:spPr>
           <a:xfrm>
-            <a:off x="8467344" y="1371600"/>
-            <a:ext cx="109728" cy="1627632"/>
-          </a:xfrm>
-          <a:prstGeom prst="roundRect">
-            <a:avLst/>
-          </a:prstGeom>
-          <a:solidFill>
-            <a:srgbClr val="4F46E5"/>
-          </a:solidFill>
-          <a:ln/>
-        </p:spPr>
-      </p:sp>
-      <p:sp>
-        <p:nvSpPr>
-          <p:cNvPr id="15" name="Text 13"/>
-          <p:cNvSpPr/>
-          <p:nvPr/>
-        </p:nvSpPr>
-        <p:spPr>
-          <a:xfrm>
-            <a:off x="8723376" y="1517904"/>
-            <a:ext cx="3236976" cy="502920"/>
-          </a:xfrm>
-          <a:prstGeom prst="rect">
-            <a:avLst/>
-          </a:prstGeom>
-          <a:noFill/>
-          <a:ln/>
-        </p:spPr>
-        <p:txBody>
-          <a:bodyPr wrap="square" lIns="0" tIns="0" rIns="0" bIns="0" rtlCol="0" anchor="t"/>
-          <a:lstStyle/>
-          <a:p>
-            <a:pPr indent="0" marL="0">
-              <a:buNone/>
-            </a:pPr>
-            <a:r>
-              <a:rPr lang="en-US" sz="1350" b="1" dirty="0">
-                <a:solidFill>
-                  <a:srgbClr val="0F172A"/>
-                </a:solidFill>
-                <a:latin typeface="Calibri" pitchFamily="34" charset="0"/>
-                <a:ea typeface="Calibri" pitchFamily="34" charset="-122"/>
-                <a:cs typeface="Calibri" pitchFamily="34" charset="-120"/>
-              </a:rPr>
-              <a:t>Chấm công ca kíp &amp; tăng ca</a:t>
-            </a:r>
-            <a:endParaRPr lang="en-US" sz="1350" dirty="0"/>
-          </a:p>
-        </p:txBody>
-      </p:sp>
-      <p:sp>
-        <p:nvSpPr>
-          <p:cNvPr id="16" name="Text 14"/>
-          <p:cNvSpPr/>
-          <p:nvPr/>
-        </p:nvSpPr>
-        <p:spPr>
-          <a:xfrm>
-            <a:off x="8723376" y="2048256"/>
-            <a:ext cx="3236976" cy="850392"/>
-          </a:xfrm>
-          <a:prstGeom prst="rect">
-            <a:avLst/>
-          </a:prstGeom>
-          <a:noFill/>
-          <a:ln/>
-        </p:spPr>
-        <p:txBody>
-          <a:bodyPr wrap="square" lIns="0" tIns="0" rIns="0" bIns="0" rtlCol="0" anchor="t"/>
-          <a:lstStyle/>
-          <a:p>
-            <a:pPr indent="0" marL="0">
-              <a:buNone/>
-            </a:pPr>
-            <a:r>
-              <a:rPr lang="en-US" sz="1050" dirty="0">
-                <a:solidFill>
-                  <a:srgbClr val="475569"/>
-                </a:solidFill>
-                <a:latin typeface="Calibri" pitchFamily="34" charset="0"/>
-                <a:ea typeface="Calibri" pitchFamily="34" charset="-122"/>
-                <a:cs typeface="Calibri" pitchFamily="34" charset="-120"/>
-              </a:rPr>
-              <a:t>3 ca 4 kíp, 150/200/300%, ca đêm</a:t>
-            </a:r>
-            <a:endParaRPr lang="en-US" sz="1050" dirty="0"/>
-          </a:p>
-        </p:txBody>
-      </p:sp>
-      <p:sp>
-        <p:nvSpPr>
-          <p:cNvPr id="17" name="Shape 15"/>
-          <p:cNvSpPr/>
-          <p:nvPr/>
-        </p:nvSpPr>
-        <p:spPr>
-          <a:xfrm>
-            <a:off x="548640" y="3200400"/>
-            <a:ext cx="3694176" cy="1627632"/>
+            <a:off x="7296912" y="1554480"/>
+            <a:ext cx="2066544" cy="2103120"/>
           </a:xfrm>
           <a:prstGeom prst="roundRect">
             <a:avLst>
-              <a:gd name="adj" fmla="val 5618"/>
+              <a:gd name="adj" fmla="val 4425"/>
             </a:avLst>
           </a:prstGeom>
           <a:solidFill>
@@ -4267,14 +4150,14 @@
       </p:sp>
       <p:sp>
         <p:nvSpPr>
-          <p:cNvPr id="18" name="Shape 16"/>
-          <p:cNvSpPr/>
-          <p:nvPr/>
-        </p:nvSpPr>
-        <p:spPr>
-          <a:xfrm>
-            <a:off x="548640" y="3200400"/>
-            <a:ext cx="109728" cy="1627632"/>
+          <p:cNvPr id="15" name="Shape 13"/>
+          <p:cNvSpPr/>
+          <p:nvPr/>
+        </p:nvSpPr>
+        <p:spPr>
+          <a:xfrm>
+            <a:off x="7296912" y="1554480"/>
+            <a:ext cx="91440" cy="2103120"/>
           </a:xfrm>
           <a:prstGeom prst="roundRect">
             <a:avLst/>
@@ -4287,14 +4170,14 @@
       </p:sp>
       <p:sp>
         <p:nvSpPr>
-          <p:cNvPr id="19" name="Text 17"/>
-          <p:cNvSpPr/>
-          <p:nvPr/>
-        </p:nvSpPr>
-        <p:spPr>
-          <a:xfrm>
-            <a:off x="804672" y="3346704"/>
-            <a:ext cx="3236976" cy="502920"/>
+          <p:cNvPr id="16" name="Text 14"/>
+          <p:cNvSpPr/>
+          <p:nvPr/>
+        </p:nvSpPr>
+        <p:spPr>
+          <a:xfrm>
+            <a:off x="7534656" y="1755648"/>
+            <a:ext cx="1664208" cy="1417320"/>
           </a:xfrm>
           <a:prstGeom prst="rect">
             <a:avLst/>
@@ -4310,7 +4193,7 @@
               <a:buNone/>
             </a:pPr>
             <a:r>
-              <a:rPr lang="en-US" sz="1350" b="1" dirty="0">
+              <a:rPr lang="en-US" sz="1300" b="1" dirty="0">
                 <a:solidFill>
                   <a:srgbClr val="0F172A"/>
                 </a:solidFill>
@@ -4320,63 +4203,24 @@
               </a:rPr>
               <a:t>Máy chấm công &amp; lương SP</a:t>
             </a:r>
-            <a:endParaRPr lang="en-US" sz="1350" dirty="0"/>
-          </a:p>
-        </p:txBody>
-      </p:sp>
-      <p:sp>
-        <p:nvSpPr>
-          <p:cNvPr id="20" name="Text 18"/>
-          <p:cNvSpPr/>
-          <p:nvPr/>
-        </p:nvSpPr>
-        <p:spPr>
-          <a:xfrm>
-            <a:off x="804672" y="3877056"/>
-            <a:ext cx="3236976" cy="850392"/>
-          </a:xfrm>
-          <a:prstGeom prst="rect">
-            <a:avLst/>
-          </a:prstGeom>
-          <a:noFill/>
-          <a:ln/>
-        </p:spPr>
-        <p:txBody>
-          <a:bodyPr wrap="square" lIns="0" tIns="0" rIns="0" bIns="0" rtlCol="0" anchor="t"/>
-          <a:lstStyle/>
-          <a:p>
-            <a:pPr indent="0" marL="0">
-              <a:buNone/>
-            </a:pPr>
-            <a:r>
-              <a:rPr lang="en-US" sz="1050" dirty="0">
-                <a:solidFill>
-                  <a:srgbClr val="475569"/>
-                </a:solidFill>
-                <a:latin typeface="Calibri" pitchFamily="34" charset="0"/>
-                <a:ea typeface="Calibri" pitchFamily="34" charset="-122"/>
-                <a:cs typeface="Calibri" pitchFamily="34" charset="-120"/>
-              </a:rPr>
-              <a:t>ZKTeco/Hikvision, lương sản phẩm/khoán</a:t>
-            </a:r>
-            <a:endParaRPr lang="en-US" sz="1050" dirty="0"/>
-          </a:p>
-        </p:txBody>
-      </p:sp>
-      <p:sp>
-        <p:nvSpPr>
-          <p:cNvPr id="21" name="Shape 19"/>
-          <p:cNvSpPr/>
-          <p:nvPr/>
-        </p:nvSpPr>
-        <p:spPr>
-          <a:xfrm>
-            <a:off x="4507992" y="3200400"/>
-            <a:ext cx="3694176" cy="1627632"/>
+            <a:endParaRPr lang="en-US" sz="1300" dirty="0"/>
+          </a:p>
+        </p:txBody>
+      </p:sp>
+      <p:sp>
+        <p:nvSpPr>
+          <p:cNvPr id="17" name="Shape 15"/>
+          <p:cNvSpPr/>
+          <p:nvPr/>
+        </p:nvSpPr>
+        <p:spPr>
+          <a:xfrm>
+            <a:off x="9546336" y="1554480"/>
+            <a:ext cx="2066544" cy="2103120"/>
           </a:xfrm>
           <a:prstGeom prst="roundRect">
             <a:avLst>
-              <a:gd name="adj" fmla="val 5618"/>
+              <a:gd name="adj" fmla="val 4425"/>
             </a:avLst>
           </a:prstGeom>
           <a:solidFill>
@@ -4399,14 +4243,14 @@
       </p:sp>
       <p:sp>
         <p:nvSpPr>
-          <p:cNvPr id="22" name="Shape 20"/>
-          <p:cNvSpPr/>
-          <p:nvPr/>
-        </p:nvSpPr>
-        <p:spPr>
-          <a:xfrm>
-            <a:off x="4507992" y="3200400"/>
-            <a:ext cx="109728" cy="1627632"/>
+          <p:cNvPr id="18" name="Shape 16"/>
+          <p:cNvSpPr/>
+          <p:nvPr/>
+        </p:nvSpPr>
+        <p:spPr>
+          <a:xfrm>
+            <a:off x="9546336" y="1554480"/>
+            <a:ext cx="91440" cy="2103120"/>
           </a:xfrm>
           <a:prstGeom prst="roundRect">
             <a:avLst/>
@@ -4419,14 +4263,14 @@
       </p:sp>
       <p:sp>
         <p:nvSpPr>
-          <p:cNvPr id="23" name="Text 21"/>
-          <p:cNvSpPr/>
-          <p:nvPr/>
-        </p:nvSpPr>
-        <p:spPr>
-          <a:xfrm>
-            <a:off x="4764024" y="3346704"/>
-            <a:ext cx="3236976" cy="502920"/>
+          <p:cNvPr id="19" name="Text 17"/>
+          <p:cNvSpPr/>
+          <p:nvPr/>
+        </p:nvSpPr>
+        <p:spPr>
+          <a:xfrm>
+            <a:off x="9784080" y="1755648"/>
+            <a:ext cx="1664208" cy="1417320"/>
           </a:xfrm>
           <a:prstGeom prst="rect">
             <a:avLst/>
@@ -4442,7 +4286,7 @@
               <a:buNone/>
             </a:pPr>
             <a:r>
-              <a:rPr lang="en-US" sz="1350" b="1" dirty="0">
+              <a:rPr lang="en-US" sz="1300" b="1" dirty="0">
                 <a:solidFill>
                   <a:srgbClr val="0F172A"/>
                 </a:solidFill>
@@ -4452,63 +4296,24 @@
               </a:rPr>
               <a:t>Kê khai điện tử</a:t>
             </a:r>
-            <a:endParaRPr lang="en-US" sz="1350" dirty="0"/>
-          </a:p>
-        </p:txBody>
-      </p:sp>
-      <p:sp>
-        <p:nvSpPr>
-          <p:cNvPr id="24" name="Text 22"/>
-          <p:cNvSpPr/>
-          <p:nvPr/>
-        </p:nvSpPr>
-        <p:spPr>
-          <a:xfrm>
-            <a:off x="4764024" y="3877056"/>
-            <a:ext cx="3236976" cy="850392"/>
-          </a:xfrm>
-          <a:prstGeom prst="rect">
-            <a:avLst/>
-          </a:prstGeom>
-          <a:noFill/>
-          <a:ln/>
-        </p:spPr>
-        <p:txBody>
-          <a:bodyPr wrap="square" lIns="0" tIns="0" rIns="0" bIns="0" rtlCol="0" anchor="t"/>
-          <a:lstStyle/>
-          <a:p>
-            <a:pPr indent="0" marL="0">
-              <a:buNone/>
-            </a:pPr>
-            <a:r>
-              <a:rPr lang="en-US" sz="1050" dirty="0">
-                <a:solidFill>
-                  <a:srgbClr val="475569"/>
-                </a:solidFill>
-                <a:latin typeface="Calibri" pitchFamily="34" charset="0"/>
-                <a:ea typeface="Calibri" pitchFamily="34" charset="-122"/>
-                <a:cs typeface="Calibri" pitchFamily="34" charset="-120"/>
-              </a:rPr>
-              <a:t>Thuế TNCN 05/KK, BHXH D02-LT → HTKK</a:t>
-            </a:r>
-            <a:endParaRPr lang="en-US" sz="1050" dirty="0"/>
-          </a:p>
-        </p:txBody>
-      </p:sp>
-      <p:sp>
-        <p:nvSpPr>
-          <p:cNvPr id="25" name="Shape 23"/>
-          <p:cNvSpPr/>
-          <p:nvPr/>
-        </p:nvSpPr>
-        <p:spPr>
-          <a:xfrm>
-            <a:off x="8467344" y="3200400"/>
-            <a:ext cx="3694176" cy="1627632"/>
+            <a:endParaRPr lang="en-US" sz="1300" dirty="0"/>
+          </a:p>
+        </p:txBody>
+      </p:sp>
+      <p:sp>
+        <p:nvSpPr>
+          <p:cNvPr id="20" name="Shape 18"/>
+          <p:cNvSpPr/>
+          <p:nvPr/>
+        </p:nvSpPr>
+        <p:spPr>
+          <a:xfrm>
+            <a:off x="548640" y="3794760"/>
+            <a:ext cx="2066544" cy="2103120"/>
           </a:xfrm>
           <a:prstGeom prst="roundRect">
             <a:avLst>
-              <a:gd name="adj" fmla="val 5618"/>
+              <a:gd name="adj" fmla="val 4425"/>
             </a:avLst>
           </a:prstGeom>
           <a:solidFill>
@@ -4531,14 +4336,14 @@
       </p:sp>
       <p:sp>
         <p:nvSpPr>
-          <p:cNvPr id="26" name="Shape 24"/>
-          <p:cNvSpPr/>
-          <p:nvPr/>
-        </p:nvSpPr>
-        <p:spPr>
-          <a:xfrm>
-            <a:off x="8467344" y="3200400"/>
-            <a:ext cx="109728" cy="1627632"/>
+          <p:cNvPr id="21" name="Shape 19"/>
+          <p:cNvSpPr/>
+          <p:nvPr/>
+        </p:nvSpPr>
+        <p:spPr>
+          <a:xfrm>
+            <a:off x="548640" y="3794760"/>
+            <a:ext cx="91440" cy="2103120"/>
           </a:xfrm>
           <a:prstGeom prst="roundRect">
             <a:avLst/>
@@ -4551,14 +4356,14 @@
       </p:sp>
       <p:sp>
         <p:nvSpPr>
-          <p:cNvPr id="27" name="Text 25"/>
-          <p:cNvSpPr/>
-          <p:nvPr/>
-        </p:nvSpPr>
-        <p:spPr>
-          <a:xfrm>
-            <a:off x="8723376" y="3346704"/>
-            <a:ext cx="3236976" cy="502920"/>
+          <p:cNvPr id="22" name="Text 20"/>
+          <p:cNvSpPr/>
+          <p:nvPr/>
+        </p:nvSpPr>
+        <p:spPr>
+          <a:xfrm>
+            <a:off x="786384" y="3995928"/>
+            <a:ext cx="1664208" cy="1417320"/>
           </a:xfrm>
           <a:prstGeom prst="rect">
             <a:avLst/>
@@ -4574,7 +4379,7 @@
               <a:buNone/>
             </a:pPr>
             <a:r>
-              <a:rPr lang="en-US" sz="1350" b="1" dirty="0">
+              <a:rPr lang="en-US" sz="1300" b="1" dirty="0">
                 <a:solidFill>
                   <a:srgbClr val="0F172A"/>
                 </a:solidFill>
@@ -4584,63 +4389,24 @@
               </a:rPr>
               <a:t>Cổng nhân viên (ESS)</a:t>
             </a:r>
-            <a:endParaRPr lang="en-US" sz="1350" dirty="0"/>
-          </a:p>
-        </p:txBody>
-      </p:sp>
-      <p:sp>
-        <p:nvSpPr>
-          <p:cNvPr id="28" name="Text 26"/>
-          <p:cNvSpPr/>
-          <p:nvPr/>
-        </p:nvSpPr>
-        <p:spPr>
-          <a:xfrm>
-            <a:off x="8723376" y="3877056"/>
-            <a:ext cx="3236976" cy="850392"/>
-          </a:xfrm>
-          <a:prstGeom prst="rect">
-            <a:avLst/>
-          </a:prstGeom>
-          <a:noFill/>
-          <a:ln/>
-        </p:spPr>
-        <p:txBody>
-          <a:bodyPr wrap="square" lIns="0" tIns="0" rIns="0" bIns="0" rtlCol="0" anchor="t"/>
-          <a:lstStyle/>
-          <a:p>
-            <a:pPr indent="0" marL="0">
-              <a:buNone/>
-            </a:pPr>
-            <a:r>
-              <a:rPr lang="en-US" sz="1050" dirty="0">
-                <a:solidFill>
-                  <a:srgbClr val="475569"/>
-                </a:solidFill>
-                <a:latin typeface="Calibri" pitchFamily="34" charset="0"/>
-                <a:ea typeface="Calibri" pitchFamily="34" charset="-122"/>
-                <a:cs typeface="Calibri" pitchFamily="34" charset="-120"/>
-              </a:rPr>
-              <a:t>Phiếu lương, xin nghỉ, tra cứu — mobile</a:t>
-            </a:r>
-            <a:endParaRPr lang="en-US" sz="1050" dirty="0"/>
-          </a:p>
-        </p:txBody>
-      </p:sp>
-      <p:sp>
-        <p:nvSpPr>
-          <p:cNvPr id="29" name="Shape 27"/>
-          <p:cNvSpPr/>
-          <p:nvPr/>
-        </p:nvSpPr>
-        <p:spPr>
-          <a:xfrm>
-            <a:off x="548640" y="5029200"/>
-            <a:ext cx="3694176" cy="1627632"/>
+            <a:endParaRPr lang="en-US" sz="1300" dirty="0"/>
+          </a:p>
+        </p:txBody>
+      </p:sp>
+      <p:sp>
+        <p:nvSpPr>
+          <p:cNvPr id="23" name="Shape 21"/>
+          <p:cNvSpPr/>
+          <p:nvPr/>
+        </p:nvSpPr>
+        <p:spPr>
+          <a:xfrm>
+            <a:off x="2798064" y="3794760"/>
+            <a:ext cx="2066544" cy="2103120"/>
           </a:xfrm>
           <a:prstGeom prst="roundRect">
             <a:avLst>
-              <a:gd name="adj" fmla="val 5618"/>
+              <a:gd name="adj" fmla="val 4425"/>
             </a:avLst>
           </a:prstGeom>
           <a:solidFill>
@@ -4663,34 +4429,34 @@
       </p:sp>
       <p:sp>
         <p:nvSpPr>
-          <p:cNvPr id="30" name="Shape 28"/>
-          <p:cNvSpPr/>
-          <p:nvPr/>
-        </p:nvSpPr>
-        <p:spPr>
-          <a:xfrm>
-            <a:off x="548640" y="5029200"/>
-            <a:ext cx="109728" cy="1627632"/>
+          <p:cNvPr id="24" name="Shape 22"/>
+          <p:cNvSpPr/>
+          <p:nvPr/>
+        </p:nvSpPr>
+        <p:spPr>
+          <a:xfrm>
+            <a:off x="2798064" y="3794760"/>
+            <a:ext cx="91440" cy="2103120"/>
           </a:xfrm>
           <a:prstGeom prst="roundRect">
             <a:avLst/>
           </a:prstGeom>
           <a:solidFill>
-            <a:srgbClr val="7C3AED"/>
-          </a:solidFill>
-          <a:ln/>
-        </p:spPr>
-      </p:sp>
-      <p:sp>
-        <p:nvSpPr>
-          <p:cNvPr id="31" name="Text 29"/>
-          <p:cNvSpPr/>
-          <p:nvPr/>
-        </p:nvSpPr>
-        <p:spPr>
-          <a:xfrm>
-            <a:off x="804672" y="5175504"/>
-            <a:ext cx="3236976" cy="502920"/>
+            <a:srgbClr val="4F46E5"/>
+          </a:solidFill>
+          <a:ln/>
+        </p:spPr>
+      </p:sp>
+      <p:sp>
+        <p:nvSpPr>
+          <p:cNvPr id="25" name="Text 23"/>
+          <p:cNvSpPr/>
+          <p:nvPr/>
+        </p:nvSpPr>
+        <p:spPr>
+          <a:xfrm>
+            <a:off x="3035808" y="3995928"/>
+            <a:ext cx="1664208" cy="1417320"/>
           </a:xfrm>
           <a:prstGeom prst="rect">
             <a:avLst/>
@@ -4706,7 +4472,7 @@
               <a:buNone/>
             </a:pPr>
             <a:r>
-              <a:rPr lang="en-US" sz="1350" b="1" dirty="0">
+              <a:rPr lang="en-US" sz="1300" b="1" dirty="0">
                 <a:solidFill>
                   <a:srgbClr val="0F172A"/>
                 </a:solidFill>
@@ -4714,65 +4480,26 @@
                 <a:ea typeface="Calibri" pitchFamily="34" charset="-122"/>
                 <a:cs typeface="Calibri" pitchFamily="34" charset="-120"/>
               </a:rPr>
-              <a:t>Đánh giá KPI / OKR</a:t>
-            </a:r>
-            <a:endParaRPr lang="en-US" sz="1350" dirty="0"/>
-          </a:p>
-        </p:txBody>
-      </p:sp>
-      <p:sp>
-        <p:nvSpPr>
-          <p:cNvPr id="32" name="Text 30"/>
-          <p:cNvSpPr/>
-          <p:nvPr/>
-        </p:nvSpPr>
-        <p:spPr>
-          <a:xfrm>
-            <a:off x="804672" y="5705856"/>
-            <a:ext cx="3236976" cy="850392"/>
-          </a:xfrm>
-          <a:prstGeom prst="rect">
-            <a:avLst/>
-          </a:prstGeom>
-          <a:noFill/>
-          <a:ln/>
-        </p:spPr>
-        <p:txBody>
-          <a:bodyPr wrap="square" lIns="0" tIns="0" rIns="0" bIns="0" rtlCol="0" anchor="t"/>
-          <a:lstStyle/>
-          <a:p>
-            <a:pPr indent="0" marL="0">
-              <a:buNone/>
-            </a:pPr>
-            <a:r>
-              <a:rPr lang="en-US" sz="1050" dirty="0">
-                <a:solidFill>
-                  <a:srgbClr val="475569"/>
-                </a:solidFill>
-                <a:latin typeface="Calibri" pitchFamily="34" charset="0"/>
-                <a:ea typeface="Calibri" pitchFamily="34" charset="-122"/>
-                <a:cs typeface="Calibri" pitchFamily="34" charset="-120"/>
-              </a:rPr>
-              <a:t>Xếp loại, mục tiêu &amp; kết quả then chốt</a:t>
-            </a:r>
-            <a:endParaRPr lang="en-US" sz="1050" dirty="0"/>
-          </a:p>
-        </p:txBody>
-      </p:sp>
-      <p:sp>
-        <p:nvSpPr>
-          <p:cNvPr id="33" name="Shape 31"/>
-          <p:cNvSpPr/>
-          <p:nvPr/>
-        </p:nvSpPr>
-        <p:spPr>
-          <a:xfrm>
-            <a:off x="4507992" y="5029200"/>
-            <a:ext cx="3694176" cy="1627632"/>
+              <a:t>Tuyển dụng (ATS)</a:t>
+            </a:r>
+            <a:endParaRPr lang="en-US" sz="1300" dirty="0"/>
+          </a:p>
+        </p:txBody>
+      </p:sp>
+      <p:sp>
+        <p:nvSpPr>
+          <p:cNvPr id="26" name="Shape 24"/>
+          <p:cNvSpPr/>
+          <p:nvPr/>
+        </p:nvSpPr>
+        <p:spPr>
+          <a:xfrm>
+            <a:off x="5047488" y="3794760"/>
+            <a:ext cx="2066544" cy="2103120"/>
           </a:xfrm>
           <a:prstGeom prst="roundRect">
             <a:avLst>
-              <a:gd name="adj" fmla="val 5618"/>
+              <a:gd name="adj" fmla="val 4425"/>
             </a:avLst>
           </a:prstGeom>
           <a:solidFill>
@@ -4795,14 +4522,14 @@
       </p:sp>
       <p:sp>
         <p:nvSpPr>
-          <p:cNvPr id="34" name="Shape 32"/>
-          <p:cNvSpPr/>
-          <p:nvPr/>
-        </p:nvSpPr>
-        <p:spPr>
-          <a:xfrm>
-            <a:off x="4507992" y="5029200"/>
-            <a:ext cx="109728" cy="1627632"/>
+          <p:cNvPr id="27" name="Shape 25"/>
+          <p:cNvSpPr/>
+          <p:nvPr/>
+        </p:nvSpPr>
+        <p:spPr>
+          <a:xfrm>
+            <a:off x="5047488" y="3794760"/>
+            <a:ext cx="91440" cy="2103120"/>
           </a:xfrm>
           <a:prstGeom prst="roundRect">
             <a:avLst/>
@@ -4815,14 +4542,14 @@
       </p:sp>
       <p:sp>
         <p:nvSpPr>
-          <p:cNvPr id="35" name="Text 33"/>
-          <p:cNvSpPr/>
-          <p:nvPr/>
-        </p:nvSpPr>
-        <p:spPr>
-          <a:xfrm>
-            <a:off x="4764024" y="5175504"/>
-            <a:ext cx="3236976" cy="502920"/>
+          <p:cNvPr id="28" name="Text 26"/>
+          <p:cNvSpPr/>
+          <p:nvPr/>
+        </p:nvSpPr>
+        <p:spPr>
+          <a:xfrm>
+            <a:off x="5285232" y="3995928"/>
+            <a:ext cx="1664208" cy="1417320"/>
           </a:xfrm>
           <a:prstGeom prst="rect">
             <a:avLst/>
@@ -4838,7 +4565,7 @@
               <a:buNone/>
             </a:pPr>
             <a:r>
-              <a:rPr lang="en-US" sz="1350" b="1" dirty="0">
+              <a:rPr lang="en-US" sz="1300" b="1" dirty="0">
                 <a:solidFill>
                   <a:srgbClr val="0F172A"/>
                 </a:solidFill>
@@ -4846,65 +4573,26 @@
                 <a:ea typeface="Calibri" pitchFamily="34" charset="-122"/>
                 <a:cs typeface="Calibri" pitchFamily="34" charset="-120"/>
               </a:rPr>
-              <a:t>Đào tạo &amp; An toàn LĐ</a:t>
-            </a:r>
-            <a:endParaRPr lang="en-US" sz="1350" dirty="0"/>
-          </a:p>
-        </p:txBody>
-      </p:sp>
-      <p:sp>
-        <p:nvSpPr>
-          <p:cNvPr id="36" name="Text 34"/>
-          <p:cNvSpPr/>
-          <p:nvPr/>
-        </p:nvSpPr>
-        <p:spPr>
-          <a:xfrm>
-            <a:off x="4764024" y="5705856"/>
-            <a:ext cx="3236976" cy="850392"/>
-          </a:xfrm>
-          <a:prstGeom prst="rect">
-            <a:avLst/>
-          </a:prstGeom>
-          <a:noFill/>
-          <a:ln/>
-        </p:spPr>
-        <p:txBody>
-          <a:bodyPr wrap="square" lIns="0" tIns="0" rIns="0" bIns="0" rtlCol="0" anchor="t"/>
-          <a:lstStyle/>
-          <a:p>
-            <a:pPr indent="0" marL="0">
-              <a:buNone/>
-            </a:pPr>
-            <a:r>
-              <a:rPr lang="en-US" sz="1050" dirty="0">
-                <a:solidFill>
-                  <a:srgbClr val="475569"/>
-                </a:solidFill>
-                <a:latin typeface="Calibri" pitchFamily="34" charset="0"/>
-                <a:ea typeface="Calibri" pitchFamily="34" charset="-122"/>
-                <a:cs typeface="Calibri" pitchFamily="34" charset="-120"/>
-              </a:rPr>
-              <a:t>LMS tự cấp chứng chỉ, khám SK, tai nạn</a:t>
-            </a:r>
-            <a:endParaRPr lang="en-US" sz="1050" dirty="0"/>
-          </a:p>
-        </p:txBody>
-      </p:sp>
-      <p:sp>
-        <p:nvSpPr>
-          <p:cNvPr id="37" name="Shape 35"/>
-          <p:cNvSpPr/>
-          <p:nvPr/>
-        </p:nvSpPr>
-        <p:spPr>
-          <a:xfrm>
-            <a:off x="8467344" y="5029200"/>
-            <a:ext cx="3694176" cy="1627632"/>
+              <a:t>Đánh giá KPI / OKR</a:t>
+            </a:r>
+            <a:endParaRPr lang="en-US" sz="1300" dirty="0"/>
+          </a:p>
+        </p:txBody>
+      </p:sp>
+      <p:sp>
+        <p:nvSpPr>
+          <p:cNvPr id="29" name="Shape 27"/>
+          <p:cNvSpPr/>
+          <p:nvPr/>
+        </p:nvSpPr>
+        <p:spPr>
+          <a:xfrm>
+            <a:off x="7296912" y="3794760"/>
+            <a:ext cx="2066544" cy="2103120"/>
           </a:xfrm>
           <a:prstGeom prst="roundRect">
             <a:avLst>
-              <a:gd name="adj" fmla="val 5618"/>
+              <a:gd name="adj" fmla="val 4425"/>
             </a:avLst>
           </a:prstGeom>
           <a:solidFill>
@@ -4927,14 +4615,14 @@
       </p:sp>
       <p:sp>
         <p:nvSpPr>
-          <p:cNvPr id="38" name="Shape 36"/>
-          <p:cNvSpPr/>
-          <p:nvPr/>
-        </p:nvSpPr>
-        <p:spPr>
-          <a:xfrm>
-            <a:off x="8467344" y="5029200"/>
-            <a:ext cx="109728" cy="1627632"/>
+          <p:cNvPr id="30" name="Shape 28"/>
+          <p:cNvSpPr/>
+          <p:nvPr/>
+        </p:nvSpPr>
+        <p:spPr>
+          <a:xfrm>
+            <a:off x="7296912" y="3794760"/>
+            <a:ext cx="91440" cy="2103120"/>
           </a:xfrm>
           <a:prstGeom prst="roundRect">
             <a:avLst/>
@@ -4947,14 +4635,14 @@
       </p:sp>
       <p:sp>
         <p:nvSpPr>
-          <p:cNvPr id="39" name="Text 37"/>
-          <p:cNvSpPr/>
-          <p:nvPr/>
-        </p:nvSpPr>
-        <p:spPr>
-          <a:xfrm>
-            <a:off x="8723376" y="5175504"/>
-            <a:ext cx="3236976" cy="502920"/>
+          <p:cNvPr id="31" name="Text 29"/>
+          <p:cNvSpPr/>
+          <p:nvPr/>
+        </p:nvSpPr>
+        <p:spPr>
+          <a:xfrm>
+            <a:off x="7534656" y="3995928"/>
+            <a:ext cx="1664208" cy="1417320"/>
           </a:xfrm>
           <a:prstGeom prst="rect">
             <a:avLst/>
@@ -4970,7 +4658,7 @@
               <a:buNone/>
             </a:pPr>
             <a:r>
-              <a:rPr lang="en-US" sz="1350" b="1" dirty="0">
+              <a:rPr lang="en-US" sz="1300" b="1" dirty="0">
                 <a:solidFill>
                   <a:srgbClr val="0F172A"/>
                 </a:solidFill>
@@ -4978,48 +4666,102 @@
                 <a:ea typeface="Calibri" pitchFamily="34" charset="-122"/>
                 <a:cs typeface="Calibri" pitchFamily="34" charset="-120"/>
               </a:rPr>
+              <a:t>Đào tạo &amp; An toàn lao động</a:t>
+            </a:r>
+            <a:endParaRPr lang="en-US" sz="1300" dirty="0"/>
+          </a:p>
+        </p:txBody>
+      </p:sp>
+      <p:sp>
+        <p:nvSpPr>
+          <p:cNvPr id="32" name="Shape 30"/>
+          <p:cNvSpPr/>
+          <p:nvPr/>
+        </p:nvSpPr>
+        <p:spPr>
+          <a:xfrm>
+            <a:off x="9546336" y="3794760"/>
+            <a:ext cx="2066544" cy="2103120"/>
+          </a:xfrm>
+          <a:prstGeom prst="roundRect">
+            <a:avLst>
+              <a:gd name="adj" fmla="val 4425"/>
+            </a:avLst>
+          </a:prstGeom>
+          <a:solidFill>
+            <a:srgbClr val="FFFFFF"/>
+          </a:solidFill>
+          <a:ln w="12700">
+            <a:solidFill>
+              <a:srgbClr val="E2E8F0"/>
+            </a:solidFill>
+            <a:prstDash val="solid"/>
+          </a:ln>
+          <a:effectLst>
+            <a:outerShdw sx="100000" sy="100000" kx="0" ky="0" algn="bl" rotWithShape="0" blurRad="114300" dist="25400" dir="8100000">
+              <a:srgbClr val="0F172A">
+                <a:alpha val="10000"/>
+              </a:srgbClr>
+            </a:outerShdw>
+          </a:effectLst>
+        </p:spPr>
+      </p:sp>
+      <p:sp>
+        <p:nvSpPr>
+          <p:cNvPr id="33" name="Shape 31"/>
+          <p:cNvSpPr/>
+          <p:nvPr/>
+        </p:nvSpPr>
+        <p:spPr>
+          <a:xfrm>
+            <a:off x="9546336" y="3794760"/>
+            <a:ext cx="91440" cy="2103120"/>
+          </a:xfrm>
+          <a:prstGeom prst="roundRect">
+            <a:avLst/>
+          </a:prstGeom>
+          <a:solidFill>
+            <a:srgbClr val="7C3AED"/>
+          </a:solidFill>
+          <a:ln/>
+        </p:spPr>
+      </p:sp>
+      <p:sp>
+        <p:nvSpPr>
+          <p:cNvPr id="34" name="Text 32"/>
+          <p:cNvSpPr/>
+          <p:nvPr/>
+        </p:nvSpPr>
+        <p:spPr>
+          <a:xfrm>
+            <a:off x="9784080" y="3995928"/>
+            <a:ext cx="1664208" cy="1417320"/>
+          </a:xfrm>
+          <a:prstGeom prst="rect">
+            <a:avLst/>
+          </a:prstGeom>
+          <a:noFill/>
+          <a:ln/>
+        </p:spPr>
+        <p:txBody>
+          <a:bodyPr wrap="square" lIns="0" tIns="0" rIns="0" bIns="0" rtlCol="0" anchor="t"/>
+          <a:lstStyle/>
+          <a:p>
+            <a:pPr indent="0" marL="0">
+              <a:buNone/>
+            </a:pPr>
+            <a:r>
+              <a:rPr lang="en-US" sz="1300" b="1" dirty="0">
+                <a:solidFill>
+                  <a:srgbClr val="0F172A"/>
+                </a:solidFill>
+                <a:latin typeface="Calibri" pitchFamily="34" charset="0"/>
+                <a:ea typeface="Calibri" pitchFamily="34" charset="-122"/>
+                <a:cs typeface="Calibri" pitchFamily="34" charset="-120"/>
+              </a:rPr>
               <a:t>Kho tri thức + Trợ lý AI</a:t>
             </a:r>
-            <a:endParaRPr lang="en-US" sz="1350" dirty="0"/>
-          </a:p>
-        </p:txBody>
-      </p:sp>
-      <p:sp>
-        <p:nvSpPr>
-          <p:cNvPr id="40" name="Text 38"/>
-          <p:cNvSpPr/>
-          <p:nvPr/>
-        </p:nvSpPr>
-        <p:spPr>
-          <a:xfrm>
-            <a:off x="8723376" y="5705856"/>
-            <a:ext cx="3236976" cy="850392"/>
-          </a:xfrm>
-          <a:prstGeom prst="rect">
-            <a:avLst/>
-          </a:prstGeom>
-          <a:noFill/>
-          <a:ln/>
-        </p:spPr>
-        <p:txBody>
-          <a:bodyPr wrap="square" lIns="0" tIns="0" rIns="0" bIns="0" rtlCol="0" anchor="t"/>
-          <a:lstStyle/>
-          <a:p>
-            <a:pPr indent="0" marL="0">
-              <a:buNone/>
-            </a:pPr>
-            <a:r>
-              <a:rPr lang="en-US" sz="1050" dirty="0">
-                <a:solidFill>
-                  <a:srgbClr val="475569"/>
-                </a:solidFill>
-                <a:latin typeface="Calibri" pitchFamily="34" charset="0"/>
-                <a:ea typeface="Calibri" pitchFamily="34" charset="-122"/>
-                <a:cs typeface="Calibri" pitchFamily="34" charset="-120"/>
-              </a:rPr>
-              <a:t>Kho tài liệu + AI hỏi-đáp (RAG)</a:t>
-            </a:r>
-            <a:endParaRPr lang="en-US" sz="1050" dirty="0"/>
+            <a:endParaRPr lang="en-US" sz="1300" dirty="0"/>
           </a:p>
         </p:txBody>
       </p:sp>
@@ -5141,7 +4883,7 @@
         </p:nvSpPr>
         <p:spPr>
           <a:xfrm>
-            <a:off x="640080" y="1600200"/>
+            <a:off x="640080" y="1481328"/>
             <a:ext cx="502920" cy="502920"/>
           </a:xfrm>
           <a:prstGeom prst="ellipse">
@@ -5161,7 +4903,7 @@
         </p:nvSpPr>
         <p:spPr>
           <a:xfrm>
-            <a:off x="640080" y="1600200"/>
+            <a:off x="640080" y="1481328"/>
             <a:ext cx="502920" cy="502920"/>
           </a:xfrm>
           <a:prstGeom prst="rect">
@@ -5200,7 +4942,7 @@
         </p:nvSpPr>
         <p:spPr>
           <a:xfrm>
-            <a:off x="1353312" y="1545336"/>
+            <a:off x="1353312" y="1426464"/>
             <a:ext cx="10259568" cy="868680"/>
           </a:xfrm>
           <a:prstGeom prst="rect">
@@ -5248,7 +4990,7 @@
                 <a:ea typeface="Calibri" pitchFamily="34" charset="-122"/>
                 <a:cs typeface="Calibri" pitchFamily="34" charset="-120"/>
               </a:rPr>
-              <a:t>Gross→net BHXH + thuế TNCN, giảm trừ gia cảnh · phiếu lương PDF · file chuyển khoản · bảng kê thuế &amp; BHXH</a:t>
+              <a:t>Gross→net BHXH + thuế TNCN · phiếu lương PDF · file chuyển khoản · bảng kê thuế &amp; BHXH</a:t>
             </a:r>
             <a:endParaRPr lang="en-US" sz="1600" dirty="0"/>
           </a:p>
@@ -5262,7 +5004,7 @@
         </p:nvSpPr>
         <p:spPr>
           <a:xfrm>
-            <a:off x="640080" y="2578608"/>
+            <a:off x="640080" y="2322576"/>
             <a:ext cx="502920" cy="502920"/>
           </a:xfrm>
           <a:prstGeom prst="ellipse">
@@ -5282,7 +5024,7 @@
         </p:nvSpPr>
         <p:spPr>
           <a:xfrm>
-            <a:off x="640080" y="2578608"/>
+            <a:off x="640080" y="2322576"/>
             <a:ext cx="502920" cy="502920"/>
           </a:xfrm>
           <a:prstGeom prst="rect">
@@ -5321,7 +5063,7 @@
         </p:nvSpPr>
         <p:spPr>
           <a:xfrm>
-            <a:off x="1353312" y="2523744"/>
+            <a:off x="1353312" y="2267712"/>
             <a:ext cx="10259568" cy="868680"/>
           </a:xfrm>
           <a:prstGeom prst="rect">
@@ -5369,7 +5111,7 @@
                 <a:ea typeface="Calibri" pitchFamily="34" charset="-122"/>
                 <a:cs typeface="Calibri" pitchFamily="34" charset="-120"/>
               </a:rPr>
-              <a:t>3 ca 4 kíp · tăng ca 150/200/300% + ca đêm (miễn thuế phần chênh) → nối thẳng vào lương</a:t>
+              <a:t>3 ca 4 kíp · tăng ca 150/200/300% + ca đêm (miễn thuế phần chênh)</a:t>
             </a:r>
             <a:endParaRPr lang="en-US" sz="1600" dirty="0"/>
           </a:p>
@@ -5383,7 +5125,7 @@
         </p:nvSpPr>
         <p:spPr>
           <a:xfrm>
-            <a:off x="640080" y="3557016"/>
+            <a:off x="640080" y="3163824"/>
             <a:ext cx="502920" cy="502920"/>
           </a:xfrm>
           <a:prstGeom prst="ellipse">
@@ -5403,7 +5145,7 @@
         </p:nvSpPr>
         <p:spPr>
           <a:xfrm>
-            <a:off x="640080" y="3557016"/>
+            <a:off x="640080" y="3163824"/>
             <a:ext cx="502920" cy="502920"/>
           </a:xfrm>
           <a:prstGeom prst="rect">
@@ -5442,7 +5184,7 @@
         </p:nvSpPr>
         <p:spPr>
           <a:xfrm>
-            <a:off x="1353312" y="3502152"/>
+            <a:off x="1353312" y="3108960"/>
             <a:ext cx="10259568" cy="868680"/>
           </a:xfrm>
           <a:prstGeom prst="rect">
@@ -5490,7 +5232,7 @@
                 <a:ea typeface="Calibri" pitchFamily="34" charset="-122"/>
                 <a:cs typeface="Calibri" pitchFamily="34" charset="-120"/>
               </a:rPr>
-              <a:t>Nhập tệp máy vân tay/khuôn mặt → bảng công · lương sản phẩm/khoán theo công đoạn</a:t>
+              <a:t>Nhập tệp máy vân tay/khuôn mặt → bảng công · lương sản phẩm/khoán</a:t>
             </a:r>
             <a:endParaRPr lang="en-US" sz="1600" dirty="0"/>
           </a:p>
@@ -5504,7 +5246,7 @@
         </p:nvSpPr>
         <p:spPr>
           <a:xfrm>
-            <a:off x="640080" y="4535424"/>
+            <a:off x="640080" y="4005072"/>
             <a:ext cx="502920" cy="502920"/>
           </a:xfrm>
           <a:prstGeom prst="ellipse">
@@ -5524,7 +5266,7 @@
         </p:nvSpPr>
         <p:spPr>
           <a:xfrm>
-            <a:off x="640080" y="4535424"/>
+            <a:off x="640080" y="4005072"/>
             <a:ext cx="502920" cy="502920"/>
           </a:xfrm>
           <a:prstGeom prst="rect">
@@ -5563,7 +5305,7 @@
         </p:nvSpPr>
         <p:spPr>
           <a:xfrm>
-            <a:off x="1353312" y="4480560"/>
+            <a:off x="1353312" y="3950208"/>
             <a:ext cx="10259568" cy="868680"/>
           </a:xfrm>
           <a:prstGeom prst="rect">
@@ -5611,7 +5353,7 @@
                 <a:ea typeface="Calibri" pitchFamily="34" charset="-122"/>
                 <a:cs typeface="Calibri" pitchFamily="34" charset="-120"/>
               </a:rPr>
-              <a:t>Tờ khai thuế TNCN (05/KK, 05-1/BK) &amp; BHXH (D02-LT) · kết xuất cho HTKK / phần mềm BHXH</a:t>
+              <a:t>Tờ khai thuế TNCN (05/KK) &amp; BHXH (D02-LT) · kết xuất cho HTKK</a:t>
             </a:r>
             <a:endParaRPr lang="en-US" sz="1600" dirty="0"/>
           </a:p>
@@ -5625,7 +5367,7 @@
         </p:nvSpPr>
         <p:spPr>
           <a:xfrm>
-            <a:off x="640080" y="5513832"/>
+            <a:off x="640080" y="4846320"/>
             <a:ext cx="502920" cy="502920"/>
           </a:xfrm>
           <a:prstGeom prst="ellipse">
@@ -5645,7 +5387,7 @@
         </p:nvSpPr>
         <p:spPr>
           <a:xfrm>
-            <a:off x="640080" y="5513832"/>
+            <a:off x="640080" y="4846320"/>
             <a:ext cx="502920" cy="502920"/>
           </a:xfrm>
           <a:prstGeom prst="rect">
@@ -5684,7 +5426,7 @@
         </p:nvSpPr>
         <p:spPr>
           <a:xfrm>
-            <a:off x="1353312" y="5458968"/>
+            <a:off x="1353312" y="4791456"/>
             <a:ext cx="10259568" cy="868680"/>
           </a:xfrm>
           <a:prstGeom prst="rect">
@@ -5732,7 +5474,128 @@
                 <a:ea typeface="Calibri" pitchFamily="34" charset="-122"/>
                 <a:cs typeface="Calibri" pitchFamily="34" charset="-120"/>
               </a:rPr>
-              <a:t>Tự xem &amp; tải phiếu lương, xem chấm công, xin nghỉ online, tra cứu tri thức — mobile</a:t>
+              <a:t>Phiếu lương, chấm công, xin nghỉ online, tra cứu tri thức — mobile</a:t>
+            </a:r>
+            <a:endParaRPr lang="en-US" sz="1600" dirty="0"/>
+          </a:p>
+        </p:txBody>
+      </p:sp>
+      <p:sp>
+        <p:nvSpPr>
+          <p:cNvPr id="19" name="Shape 17"/>
+          <p:cNvSpPr/>
+          <p:nvPr/>
+        </p:nvSpPr>
+        <p:spPr>
+          <a:xfrm>
+            <a:off x="640080" y="5687568"/>
+            <a:ext cx="502920" cy="502920"/>
+          </a:xfrm>
+          <a:prstGeom prst="ellipse">
+            <a:avLst/>
+          </a:prstGeom>
+          <a:solidFill>
+            <a:srgbClr val="4F46E5"/>
+          </a:solidFill>
+          <a:ln/>
+        </p:spPr>
+      </p:sp>
+      <p:sp>
+        <p:nvSpPr>
+          <p:cNvPr id="20" name="Text 18"/>
+          <p:cNvSpPr/>
+          <p:nvPr/>
+        </p:nvSpPr>
+        <p:spPr>
+          <a:xfrm>
+            <a:off x="640080" y="5687568"/>
+            <a:ext cx="502920" cy="502920"/>
+          </a:xfrm>
+          <a:prstGeom prst="rect">
+            <a:avLst/>
+          </a:prstGeom>
+          <a:noFill/>
+          <a:ln/>
+        </p:spPr>
+        <p:txBody>
+          <a:bodyPr wrap="square" lIns="0" tIns="0" rIns="0" bIns="0" rtlCol="0" anchor="ctr"/>
+          <a:lstStyle/>
+          <a:p>
+            <a:pPr algn="ctr" indent="0" marL="0">
+              <a:buNone/>
+            </a:pPr>
+            <a:r>
+              <a:rPr lang="en-US" sz="1800" b="1" dirty="0">
+                <a:solidFill>
+                  <a:srgbClr val="FFFFFF"/>
+                </a:solidFill>
+                <a:latin typeface="Calibri" pitchFamily="34" charset="0"/>
+                <a:ea typeface="Calibri" pitchFamily="34" charset="-122"/>
+                <a:cs typeface="Calibri" pitchFamily="34" charset="-120"/>
+              </a:rPr>
+              <a:t>6</a:t>
+            </a:r>
+            <a:endParaRPr lang="en-US" sz="1800" dirty="0"/>
+          </a:p>
+        </p:txBody>
+      </p:sp>
+      <p:sp>
+        <p:nvSpPr>
+          <p:cNvPr id="21" name="Text 19"/>
+          <p:cNvSpPr/>
+          <p:nvPr/>
+        </p:nvSpPr>
+        <p:spPr>
+          <a:xfrm>
+            <a:off x="1353312" y="5632704"/>
+            <a:ext cx="10259568" cy="868680"/>
+          </a:xfrm>
+          <a:prstGeom prst="rect">
+            <a:avLst/>
+          </a:prstGeom>
+          <a:noFill/>
+          <a:ln/>
+        </p:spPr>
+        <p:txBody>
+          <a:bodyPr wrap="square" lIns="0" tIns="0" rIns="0" bIns="0" rtlCol="0" anchor="t"/>
+          <a:lstStyle/>
+          <a:p>
+            <a:pPr indent="0" marL="0">
+              <a:spcAft>
+                <a:spcPts val="200"/>
+              </a:spcAft>
+              <a:buNone/>
+            </a:pPr>
+            <a:r>
+              <a:rPr lang="en-US" sz="1600" b="1" dirty="0">
+                <a:solidFill>
+                  <a:srgbClr val="0F172A"/>
+                </a:solidFill>
+                <a:latin typeface="Calibri" pitchFamily="34" charset="0"/>
+                <a:ea typeface="Calibri" pitchFamily="34" charset="-122"/>
+                <a:cs typeface="Calibri" pitchFamily="34" charset="-120"/>
+              </a:rPr>
+              <a:t>Tuyển dụng (ATS)</a:t>
+            </a:r>
+            <a:endParaRPr lang="en-US" sz="1600" dirty="0"/>
+          </a:p>
+          <a:p>
+            <a:pPr indent="0" marL="0">
+              <a:spcAft>
+                <a:spcPts val="200"/>
+              </a:spcAft>
+              <a:buNone/>
+            </a:pPr>
+            <a:r>
+              <a:rPr lang="en-US" sz="1250" dirty="0">
+                <a:solidFill>
+                  <a:srgbClr val="475569"/>
+                </a:solidFill>
+                <a:latin typeface="Calibri" pitchFamily="34" charset="0"/>
+                <a:ea typeface="Calibri" pitchFamily="34" charset="-122"/>
+                <a:cs typeface="Calibri" pitchFamily="34" charset="-120"/>
+              </a:rPr>
+              <a:t>Yêu cầu TD + duyệt · pipeline ứng viên · chấm điểm PV · tạo NV từ ứng viên</a:t>
             </a:r>
             <a:endParaRPr lang="en-US" sz="1600" dirty="0"/>
           </a:p>
@@ -8300,7 +8163,7 @@
                 <a:ea typeface="Calibri" pitchFamily="34" charset="-122"/>
                 <a:cs typeface="Calibri" pitchFamily="34" charset="-120"/>
               </a:rPr>
-              <a:t>9</a:t>
+              <a:t>10</a:t>
             </a:r>
             <a:endParaRPr lang="en-US" sz="4000" dirty="0"/>
           </a:p>

</xml_diff>

<commit_message>
content: hạ ngưỡng miễn phí 30 → 20 nhân viên (toàn bộ collateral)
sapiones.com (landing + meta), overview, features, release-notes, brochure
(HTML+PDF), pitch deck (JS+PPTX) — đồng bộ "miễn phí tới 20 nhân viên".

Co-Authored-By: Claude Opus 4.8 <noreply@anthropic.com>
</commit_message>
<xml_diff>
--- a/brand/Sapiones-pitch.pptx
+++ b/brand/Sapiones-pitch.pptx
@@ -1916,7 +1916,7 @@
                 <a:ea typeface="Calibri" pitchFamily="34" charset="-122"/>
                 <a:cs typeface="Calibri" pitchFamily="34" charset="-120"/>
               </a:rPr>
-              <a:t>✓  Miễn phí tới 30 nhân viên — không giới hạn thời gian</a:t>
+              <a:t>✓  Miễn phí tới 20 nhân viên — không giới hạn thời gian</a:t>
             </a:r>
             <a:endParaRPr lang="en-US" sz="1250" dirty="0"/>
           </a:p>
@@ -3361,7 +3361,7 @@
                 <a:ea typeface="Calibri" pitchFamily="34" charset="-122"/>
                 <a:cs typeface="Calibri" pitchFamily="34" charset="-120"/>
               </a:rPr>
-              <a:t>Mã nguồn mở phần lõi, chủ quyền dữ liệu, miễn phí tới 30 nhân viên.</a:t>
+              <a:t>Mã nguồn mở phần lõi, chủ quyền dữ liệu, miễn phí tới 20 nhân viên.</a:t>
             </a:r>
             <a:endParaRPr lang="en-US" sz="1700" dirty="0"/>
           </a:p>
@@ -4869,7 +4869,7 @@
                 <a:ea typeface="Calibri" pitchFamily="34" charset="-122"/>
                 <a:cs typeface="Calibri" pitchFamily="34" charset="-120"/>
               </a:rPr>
-              <a:t>Cho doanh nghiệp &gt; 30 nhân viên</a:t>
+              <a:t>Cho doanh nghiệp &gt; 20 nhân viên</a:t>
             </a:r>
             <a:endParaRPr lang="en-US" sz="1500" dirty="0"/>
           </a:p>
@@ -7200,7 +7200,7 @@
                 <a:ea typeface="Calibri" pitchFamily="34" charset="-122"/>
                 <a:cs typeface="Calibri" pitchFamily="34" charset="-120"/>
               </a:rPr>
-              <a:t>Mô hình mở — Miễn phí tới 30 nhân viên</a:t>
+              <a:t>Mô hình mở — Miễn phí tới 20 nhân viên</a:t>
             </a:r>
             <a:endParaRPr lang="en-US" sz="3100" dirty="0"/>
           </a:p>
@@ -7371,7 +7371,7 @@
                 <a:ea typeface="Calibri" pitchFamily="34" charset="-122"/>
                 <a:cs typeface="Calibri" pitchFamily="34" charset="-120"/>
               </a:rPr>
-              <a:t>≤ 30 nhân viên</a:t>
+              <a:t>≤ 20 nhân viên</a:t>
             </a:r>
             <a:endParaRPr lang="en-US" sz="1250" dirty="0"/>
           </a:p>
@@ -7609,7 +7609,7 @@
                 <a:ea typeface="Calibri" pitchFamily="34" charset="-122"/>
                 <a:cs typeface="Calibri" pitchFamily="34" charset="-120"/>
               </a:rPr>
-              <a:t>Doanh nghiệp &gt; 30 NV</a:t>
+              <a:t>Doanh nghiệp &gt; 20 NV</a:t>
             </a:r>
             <a:endParaRPr lang="en-US" sz="1250" dirty="0"/>
           </a:p>

</xml_diff>